<commit_message>
W02/D5: S33 shows its check, the cheat sheet warns about XLOOKUP, lab problem 2 described as built
S33 now carries the check on the slide as well as in its notes. Panel 3 of the cheat sheet says
LibreOffice 24.2 returns #NAME? for XLOOKUP, as the deck notes and study notes do, and the PDF is
rebuilt. The lab solution describes problem 2 as the three cards it holds, the third of which points
the wrong way. The day sheet tells the trainer that the take-home table's 311 rows fall past
Friday's ranges and that the self-check catches it.

Co-Authored-By: Claude Opus 5.5 <noreply@anthropic.com>
Claude-Session: https://claude.ai/code/session_01P7zaoR4dQ5pzBFnsX549JQ
</commit_message>
<xml_diff>
--- a/content/W02/D5/slides/C2_W02_D05_half1_STUDENT.pptx
+++ b/content/W02/D5/slides/C2_W02_D05_half1_STUDENT.pptx
@@ -18353,7 +18353,7 @@
                 </a:solidFill>
                 <a:latin typeface="Calibri"/>
               </a:rPr>
-              <a:t>Week 2 Day 5: the number reaches the leadership deck</a:t>
+              <a:t>Week 2, Day 5. The number reaches the leadership deck</a:t>
             </a:r>
           </a:p>
         </p:txBody>
@@ -22617,7 +22617,7 @@
                 </a:solidFill>
                 <a:latin typeface="Calibri"/>
               </a:rPr>
-              <a:t>Week 2 Day 5: the number reaches the leadership deck</a:t>
+              <a:t>Week 2, Day 5. The number reaches the leadership deck</a:t>
             </a:r>
           </a:p>
         </p:txBody>
@@ -35225,7 +35225,7 @@
                 </a:solidFill>
                 <a:latin typeface="Calibri"/>
               </a:rPr>
-              <a:t>Week 2 Day 5: the number reaches the leadership deck</a:t>
+              <a:t>Week 2, Day 5. The number reaches the leadership deck</a:t>
             </a:r>
           </a:p>
         </p:txBody>
@@ -38731,7 +38731,7 @@
         <p:spPr>
           <a:xfrm>
             <a:off x="530352" y="3419856"/>
-            <a:ext cx="11130991" cy="772160"/>
+            <a:ext cx="11130991" cy="1048512"/>
           </a:xfrm>
           <a:prstGeom prst="rect">
             <a:avLst/>
@@ -38757,6 +38757,24 @@
                 <a:latin typeface="Calibri"/>
               </a:rPr>
               <a:t>The answer is b. </a:t>
+            </a:r>
+            <a:r>
+              <a:rPr sz="1600" b="1" i="0">
+                <a:solidFill>
+                  <a:srgbClr val="1A1440"/>
+                </a:solidFill>
+                <a:latin typeface="Calibri"/>
+              </a:rPr>
+              <a:t>The check:</a:t>
+            </a:r>
+            <a:r>
+              <a:rPr sz="1600" b="0" i="0">
+                <a:solidFill>
+                  <a:srgbClr val="1A1440"/>
+                </a:solidFill>
+                <a:latin typeface="Calibri"/>
+              </a:rPr>
+              <a:t> read the card aloud and ask which months, and against what; a card that cannot answer is not ready. </a:t>
             </a:r>
             <a:r>
               <a:rPr sz="1600" b="1" i="0">
@@ -49945,7 +49963,7 @@
                 </a:solidFill>
                 <a:latin typeface="Calibri"/>
               </a:rPr>
-              <a:t>Week 2 Day 5: the number reaches the leadership deck</a:t>
+              <a:t>Week 2, Day 5. The number reaches the leadership deck</a:t>
             </a:r>
           </a:p>
         </p:txBody>

</xml_diff>